<commit_message>
docs: align presentation code references
</commit_message>
<xml_diff>
--- a/VisitReady-Agent-答辩.pptx
+++ b/VisitReady-Agent-答辩.pptx
@@ -2,20 +2,20 @@
 <file path=ppt/presentation.xml><?xml version="1.0" encoding="utf-8"?>
 <p:presentation xmlns:p="http://schemas.openxmlformats.org/presentationml/2006/main">
   <p:sldMasterIdLst>
-    <p:sldMasterId xmlns:r="http://schemas.openxmlformats.org/officeDocument/2006/relationships" id="2147483648" r:id="Rd2163fa99ac94dcf"/>
+    <p:sldMasterId xmlns:r="http://schemas.openxmlformats.org/officeDocument/2006/relationships" id="2147483648" r:id="R75ded3cc17a34513"/>
   </p:sldMasterIdLst>
   <p:notesMasterIdLst>
-    <p:notesMasterId xmlns:r="http://schemas.openxmlformats.org/officeDocument/2006/relationships" r:id="R6b15992b7bdf4e03"/>
+    <p:notesMasterId xmlns:r="http://schemas.openxmlformats.org/officeDocument/2006/relationships" r:id="Rab7f9f52ad714009"/>
   </p:notesMasterIdLst>
   <p:sldIdLst>
-    <p:sldId xmlns:r="http://schemas.openxmlformats.org/officeDocument/2006/relationships" id="256" r:id="Rb606f71c8c264e1d"/>
-    <p:sldId xmlns:r="http://schemas.openxmlformats.org/officeDocument/2006/relationships" id="257" r:id="Rf3120ce66578404f"/>
-    <p:sldId xmlns:r="http://schemas.openxmlformats.org/officeDocument/2006/relationships" id="258" r:id="R12f05c12eae44697"/>
-    <p:sldId xmlns:r="http://schemas.openxmlformats.org/officeDocument/2006/relationships" id="259" r:id="Re8390c793af34747"/>
-    <p:sldId xmlns:r="http://schemas.openxmlformats.org/officeDocument/2006/relationships" id="260" r:id="Rece112d5b4c840b7"/>
-    <p:sldId xmlns:r="http://schemas.openxmlformats.org/officeDocument/2006/relationships" id="261" r:id="Rf5017eacb55e43e3"/>
-    <p:sldId xmlns:r="http://schemas.openxmlformats.org/officeDocument/2006/relationships" id="262" r:id="Ra2fadf70e5df42be"/>
-    <p:sldId xmlns:r="http://schemas.openxmlformats.org/officeDocument/2006/relationships" id="263" r:id="R3b2450722f7a4d9a"/>
+    <p:sldId xmlns:r="http://schemas.openxmlformats.org/officeDocument/2006/relationships" id="256" r:id="Rb0e9ef892dd3469c"/>
+    <p:sldId xmlns:r="http://schemas.openxmlformats.org/officeDocument/2006/relationships" id="257" r:id="Rfe4b6a4fce1f447f"/>
+    <p:sldId xmlns:r="http://schemas.openxmlformats.org/officeDocument/2006/relationships" id="258" r:id="R545359f948814e87"/>
+    <p:sldId xmlns:r="http://schemas.openxmlformats.org/officeDocument/2006/relationships" id="259" r:id="R66250a8d2dce4d6b"/>
+    <p:sldId xmlns:r="http://schemas.openxmlformats.org/officeDocument/2006/relationships" id="260" r:id="R1b5f24f8c04148b8"/>
+    <p:sldId xmlns:r="http://schemas.openxmlformats.org/officeDocument/2006/relationships" id="261" r:id="R847c2b55e96240bd"/>
+    <p:sldId xmlns:r="http://schemas.openxmlformats.org/officeDocument/2006/relationships" id="262" r:id="Rcbfc1e92f0334dba"/>
+    <p:sldId xmlns:r="http://schemas.openxmlformats.org/officeDocument/2006/relationships" id="263" r:id="R6f340c242cca4e8a"/>
   </p:sldIdLst>
   <p:sldSz cx="12192000" cy="6858000"/>
   <p:notesSz cx="6858000" cy="9144000"/>
@@ -839,7 +839,7 @@
           </a:p>
           <a:p xmlns:a="http://schemas.openxmlformats.org/drawingml/2006/main">
             <a:r>
-              <a:t>- internal/webui/assets/app.js:159-193</a:t>
+              <a:t>- internal/webui/assets/app.js:166-200</a:t>
             </a:r>
           </a:p>
         </p:txBody>
@@ -1192,7 +1192,7 @@
   </p:cSld>
   <p:clrMap bg1="lt1" tx1="dk1" bg2="lt2" tx2="dk2" accent1="accent1" accent2="accent2" accent3="accent3" accent4="accent4" accent5="accent5" accent6="accent6" hlink="hlink" folHlink="folHlink"/>
   <p:sldLayoutIdLst>
-    <p:sldLayoutId xmlns:r="http://schemas.openxmlformats.org/officeDocument/2006/relationships" id="2147483649" r:id="R0a3d3357583a47a3"/>
+    <p:sldLayoutId xmlns:r="http://schemas.openxmlformats.org/officeDocument/2006/relationships" id="2147483649" r:id="R876e849e8a404a25"/>
   </p:sldLayoutIdLst>
   <p:txStyles>
     <p:titleStyle>
@@ -1743,7 +1743,7 @@
           <p:cNvPr id="8" name="cover-kicker">
             <a:extLst xmlns:a="http://schemas.openxmlformats.org/drawingml/2006/main">
               <a:ext uri="{FF2B5EF4-FFF2-40B4-BE49-F238E27FC236}">
-                <a16:creationId xmlns:a16="http://schemas.microsoft.com/office/drawing/2014/main" id="{1A3F69F5-6D9B-4529-8B17-3CA6194534CA}"/>
+                <a16:creationId xmlns:a16="http://schemas.microsoft.com/office/drawing/2014/main" id="{FD515F18-4E07-4617-AD3F-24946E6AE79C}"/>
               </a:ext>
             </a:extLst>
           </p:cNvPr>
@@ -1801,7 +1801,7 @@
           <p:cNvPr id="2" name="cover-title">
             <a:extLst xmlns:a="http://schemas.openxmlformats.org/drawingml/2006/main">
               <a:ext uri="{FF2B5EF4-FFF2-40B4-BE49-F238E27FC236}">
-                <a16:creationId xmlns:a16="http://schemas.microsoft.com/office/drawing/2014/main" id="{035F4D4C-AEFB-4CD0-876C-8A58026B43BD}"/>
+                <a16:creationId xmlns:a16="http://schemas.microsoft.com/office/drawing/2014/main" id="{104CEC81-8171-488E-9974-D2E7DD735E1F}"/>
               </a:ext>
             </a:extLst>
           </p:cNvPr>
@@ -1882,7 +1882,7 @@
           <p:cNvPr id="3" name="cover-subtitle">
             <a:extLst xmlns:a="http://schemas.openxmlformats.org/drawingml/2006/main">
               <a:ext uri="{FF2B5EF4-FFF2-40B4-BE49-F238E27FC236}">
-                <a16:creationId xmlns:a16="http://schemas.microsoft.com/office/drawing/2014/main" id="{FBF2124D-C891-4CEB-9A26-D90D5A578E25}"/>
+                <a16:creationId xmlns:a16="http://schemas.microsoft.com/office/drawing/2014/main" id="{C70A192E-700A-4568-8139-2FAF6DCBE12B}"/>
               </a:ext>
             </a:extLst>
           </p:cNvPr>
@@ -1940,7 +1940,7 @@
           <p:cNvPr id="4" name="cover-rule">
             <a:extLst xmlns:a="http://schemas.openxmlformats.org/drawingml/2006/main">
               <a:ext uri="{FF2B5EF4-FFF2-40B4-BE49-F238E27FC236}">
-                <a16:creationId xmlns:a16="http://schemas.microsoft.com/office/drawing/2014/main" id="{A8294838-D10D-4E11-8882-D80F3F48D6C7}"/>
+                <a16:creationId xmlns:a16="http://schemas.microsoft.com/office/drawing/2014/main" id="{56C9AEC0-F968-492A-ABAC-622B2D679243}"/>
               </a:ext>
             </a:extLst>
           </p:cNvPr>
@@ -1973,7 +1973,7 @@
           <p:cNvPr id="5" name="cover-stack">
             <a:extLst xmlns:a="http://schemas.openxmlformats.org/drawingml/2006/main">
               <a:ext uri="{FF2B5EF4-FFF2-40B4-BE49-F238E27FC236}">
-                <a16:creationId xmlns:a16="http://schemas.microsoft.com/office/drawing/2014/main" id="{44331EEC-B286-4052-A176-AB547D4BB7B9}"/>
+                <a16:creationId xmlns:a16="http://schemas.microsoft.com/office/drawing/2014/main" id="{E2911B5E-DD40-4ADB-97C8-26A740D49636}"/>
               </a:ext>
             </a:extLst>
           </p:cNvPr>
@@ -2031,7 +2031,7 @@
           <p:cNvPr id="6" name="cover-boundary">
             <a:extLst xmlns:a="http://schemas.openxmlformats.org/drawingml/2006/main">
               <a:ext uri="{FF2B5EF4-FFF2-40B4-BE49-F238E27FC236}">
-                <a16:creationId xmlns:a16="http://schemas.microsoft.com/office/drawing/2014/main" id="{A5C3ECDF-03DF-4082-85FB-517EA192485E}"/>
+                <a16:creationId xmlns:a16="http://schemas.microsoft.com/office/drawing/2014/main" id="{B10FA2D4-6B99-4EC9-89D1-5C09E735BF89}"/>
               </a:ext>
             </a:extLst>
           </p:cNvPr>
@@ -2089,7 +2089,7 @@
           <p:cNvPr id="7" name="cover-page">
             <a:extLst xmlns:a="http://schemas.openxmlformats.org/drawingml/2006/main">
               <a:ext uri="{FF2B5EF4-FFF2-40B4-BE49-F238E27FC236}">
-                <a16:creationId xmlns:a16="http://schemas.microsoft.com/office/drawing/2014/main" id="{7EC5F6D8-9408-4520-B8A3-C1DE5531967F}"/>
+                <a16:creationId xmlns:a16="http://schemas.microsoft.com/office/drawing/2014/main" id="{0F3A767D-39F1-4C76-9CBA-9B8D15FA92E2}"/>
               </a:ext>
             </a:extLst>
           </p:cNvPr>
@@ -2145,7 +2145,7 @@
     </p:spTree>
     <p:extLst>
       <p:ext uri="{BB962C8B-B14F-4D97-AF65-F5344CB8AC3E}">
-        <p14:creationId xmlns:p14="http://schemas.microsoft.com/office/powerpoint/2010/main" val="151025045"/>
+        <p14:creationId xmlns:p14="http://schemas.microsoft.com/office/powerpoint/2010/main" val="1308835688"/>
       </p:ext>
     </p:extLst>
   </p:cSld>
@@ -2176,7 +2176,7 @@
           <p:cNvPr id="16" name="kicker-2">
             <a:extLst xmlns:a="http://schemas.openxmlformats.org/drawingml/2006/main">
               <a:ext uri="{FF2B5EF4-FFF2-40B4-BE49-F238E27FC236}">
-                <a16:creationId xmlns:a16="http://schemas.microsoft.com/office/drawing/2014/main" id="{696D4D7A-5335-4B98-942E-4DBBC40BDD78}"/>
+                <a16:creationId xmlns:a16="http://schemas.microsoft.com/office/drawing/2014/main" id="{A02238BD-5045-4FEB-A7F4-C0B71C62A059}"/>
               </a:ext>
             </a:extLst>
           </p:cNvPr>
@@ -2234,7 +2234,7 @@
           <p:cNvPr id="2" name="title-2">
             <a:extLst xmlns:a="http://schemas.openxmlformats.org/drawingml/2006/main">
               <a:ext uri="{FF2B5EF4-FFF2-40B4-BE49-F238E27FC236}">
-                <a16:creationId xmlns:a16="http://schemas.microsoft.com/office/drawing/2014/main" id="{7A07D373-6A3A-46A4-ADEF-73294D19845F}"/>
+                <a16:creationId xmlns:a16="http://schemas.microsoft.com/office/drawing/2014/main" id="{C54471AD-D841-415D-81E2-FF022DAF7025}"/>
               </a:ext>
             </a:extLst>
           </p:cNvPr>
@@ -2292,7 +2292,7 @@
           <p:cNvPr id="3" name="header-rule-2">
             <a:extLst xmlns:a="http://schemas.openxmlformats.org/drawingml/2006/main">
               <a:ext uri="{FF2B5EF4-FFF2-40B4-BE49-F238E27FC236}">
-                <a16:creationId xmlns:a16="http://schemas.microsoft.com/office/drawing/2014/main" id="{0A794709-5EB4-400C-BD92-CAD6D071A663}"/>
+                <a16:creationId xmlns:a16="http://schemas.microsoft.com/office/drawing/2014/main" id="{015A726E-6CAE-4C39-A2C4-32E1657EF231}"/>
               </a:ext>
             </a:extLst>
           </p:cNvPr>
@@ -2325,7 +2325,7 @@
           <p:cNvPr id="4" name="page-2">
             <a:extLst xmlns:a="http://schemas.openxmlformats.org/drawingml/2006/main">
               <a:ext uri="{FF2B5EF4-FFF2-40B4-BE49-F238E27FC236}">
-                <a16:creationId xmlns:a16="http://schemas.microsoft.com/office/drawing/2014/main" id="{479A2CA0-42BD-4A84-B774-3F82ACAD5BC0}"/>
+                <a16:creationId xmlns:a16="http://schemas.microsoft.com/office/drawing/2014/main" id="{F762DCD4-7295-407C-B84C-632195CEBE38}"/>
               </a:ext>
             </a:extLst>
           </p:cNvPr>
@@ -2387,7 +2387,7 @@
           <p:nvPr/>
         </p:nvPicPr>
         <p:blipFill>
-          <a:blip xmlns:r="http://schemas.openxmlformats.org/officeDocument/2006/relationships" xmlns:a="http://schemas.openxmlformats.org/drawingml/2006/main" r:embed="Re912118783314cf8"/>
+          <a:blip xmlns:r="http://schemas.openxmlformats.org/officeDocument/2006/relationships" xmlns:a="http://schemas.openxmlformats.org/drawingml/2006/main" r:embed="R5dba081c2bef4420"/>
           <a:stretch xmlns:a="http://schemas.openxmlformats.org/drawingml/2006/main"/>
         </p:blipFill>
         <p:spPr>
@@ -2407,7 +2407,7 @@
           <p:cNvPr id="6" name="screenshot-border">
             <a:extLst xmlns:a="http://schemas.openxmlformats.org/drawingml/2006/main">
               <a:ext uri="{FF2B5EF4-FFF2-40B4-BE49-F238E27FC236}">
-                <a16:creationId xmlns:a16="http://schemas.microsoft.com/office/drawing/2014/main" id="{060C9BDB-9B2F-4D55-B626-54CDF13D7960}"/>
+                <a16:creationId xmlns:a16="http://schemas.microsoft.com/office/drawing/2014/main" id="{EB495683-518A-455E-B53D-1C7B834AC802}"/>
               </a:ext>
             </a:extLst>
           </p:cNvPr>
@@ -2440,7 +2440,7 @@
           <p:cNvPr id="7" name="result-1-accent">
             <a:extLst xmlns:a="http://schemas.openxmlformats.org/drawingml/2006/main">
               <a:ext uri="{FF2B5EF4-FFF2-40B4-BE49-F238E27FC236}">
-                <a16:creationId xmlns:a16="http://schemas.microsoft.com/office/drawing/2014/main" id="{AD5E582A-265E-4045-B354-729DB2C7C397}"/>
+                <a16:creationId xmlns:a16="http://schemas.microsoft.com/office/drawing/2014/main" id="{BDD64818-8FAB-4935-94BC-CA9C99694EDE}"/>
               </a:ext>
             </a:extLst>
           </p:cNvPr>
@@ -2473,7 +2473,7 @@
           <p:cNvPr id="8" name="result-1-heading">
             <a:extLst xmlns:a="http://schemas.openxmlformats.org/drawingml/2006/main">
               <a:ext uri="{FF2B5EF4-FFF2-40B4-BE49-F238E27FC236}">
-                <a16:creationId xmlns:a16="http://schemas.microsoft.com/office/drawing/2014/main" id="{8F702993-0ACE-4268-9D22-EC2EFD173E58}"/>
+                <a16:creationId xmlns:a16="http://schemas.microsoft.com/office/drawing/2014/main" id="{A31BB810-7C51-452E-96DD-EB332F66BD3E}"/>
               </a:ext>
             </a:extLst>
           </p:cNvPr>
@@ -2531,7 +2531,7 @@
           <p:cNvPr id="9" name="result-1-body">
             <a:extLst xmlns:a="http://schemas.openxmlformats.org/drawingml/2006/main">
               <a:ext uri="{FF2B5EF4-FFF2-40B4-BE49-F238E27FC236}">
-                <a16:creationId xmlns:a16="http://schemas.microsoft.com/office/drawing/2014/main" id="{97F19603-7632-49F0-A33E-F3C97E22FB6C}"/>
+                <a16:creationId xmlns:a16="http://schemas.microsoft.com/office/drawing/2014/main" id="{0B9DE72C-46CC-4DAA-88C2-504A3B396A40}"/>
               </a:ext>
             </a:extLst>
           </p:cNvPr>
@@ -2589,7 +2589,7 @@
           <p:cNvPr id="10" name="result-2-accent">
             <a:extLst xmlns:a="http://schemas.openxmlformats.org/drawingml/2006/main">
               <a:ext uri="{FF2B5EF4-FFF2-40B4-BE49-F238E27FC236}">
-                <a16:creationId xmlns:a16="http://schemas.microsoft.com/office/drawing/2014/main" id="{74335155-91AB-4929-AE87-C8E10B744ACA}"/>
+                <a16:creationId xmlns:a16="http://schemas.microsoft.com/office/drawing/2014/main" id="{7D8BDF76-E24B-447E-84AC-643EE7253E92}"/>
               </a:ext>
             </a:extLst>
           </p:cNvPr>
@@ -2622,7 +2622,7 @@
           <p:cNvPr id="11" name="result-2-heading">
             <a:extLst xmlns:a="http://schemas.openxmlformats.org/drawingml/2006/main">
               <a:ext uri="{FF2B5EF4-FFF2-40B4-BE49-F238E27FC236}">
-                <a16:creationId xmlns:a16="http://schemas.microsoft.com/office/drawing/2014/main" id="{865A9335-AE26-4772-AF1D-0F4EFAD1F37E}"/>
+                <a16:creationId xmlns:a16="http://schemas.microsoft.com/office/drawing/2014/main" id="{5C73AFE5-2C8D-4CD0-B1FE-6427C9F0F380}"/>
               </a:ext>
             </a:extLst>
           </p:cNvPr>
@@ -2680,7 +2680,7 @@
           <p:cNvPr id="12" name="result-2-body">
             <a:extLst xmlns:a="http://schemas.openxmlformats.org/drawingml/2006/main">
               <a:ext uri="{FF2B5EF4-FFF2-40B4-BE49-F238E27FC236}">
-                <a16:creationId xmlns:a16="http://schemas.microsoft.com/office/drawing/2014/main" id="{D3AFA002-19A9-41F8-905D-37B2DAD7DD3A}"/>
+                <a16:creationId xmlns:a16="http://schemas.microsoft.com/office/drawing/2014/main" id="{D0E25D8C-E70B-4422-B29B-2C51CA88680D}"/>
               </a:ext>
             </a:extLst>
           </p:cNvPr>
@@ -2738,7 +2738,7 @@
           <p:cNvPr id="13" name="result-3-accent">
             <a:extLst xmlns:a="http://schemas.openxmlformats.org/drawingml/2006/main">
               <a:ext uri="{FF2B5EF4-FFF2-40B4-BE49-F238E27FC236}">
-                <a16:creationId xmlns:a16="http://schemas.microsoft.com/office/drawing/2014/main" id="{6DA88F63-1E73-43C3-A870-6316F1B48C0E}"/>
+                <a16:creationId xmlns:a16="http://schemas.microsoft.com/office/drawing/2014/main" id="{1A3157CB-4F0E-402D-8DDC-238E84AA5509}"/>
               </a:ext>
             </a:extLst>
           </p:cNvPr>
@@ -2771,7 +2771,7 @@
           <p:cNvPr id="14" name="result-3-heading">
             <a:extLst xmlns:a="http://schemas.openxmlformats.org/drawingml/2006/main">
               <a:ext uri="{FF2B5EF4-FFF2-40B4-BE49-F238E27FC236}">
-                <a16:creationId xmlns:a16="http://schemas.microsoft.com/office/drawing/2014/main" id="{623300B2-84C1-4C26-BBAC-4ED7DD1CD1AB}"/>
+                <a16:creationId xmlns:a16="http://schemas.microsoft.com/office/drawing/2014/main" id="{659CBD28-F3F5-4093-AD0D-7D4F1ACB4935}"/>
               </a:ext>
             </a:extLst>
           </p:cNvPr>
@@ -2829,7 +2829,7 @@
           <p:cNvPr id="15" name="result-3-body">
             <a:extLst xmlns:a="http://schemas.openxmlformats.org/drawingml/2006/main">
               <a:ext uri="{FF2B5EF4-FFF2-40B4-BE49-F238E27FC236}">
-                <a16:creationId xmlns:a16="http://schemas.microsoft.com/office/drawing/2014/main" id="{63B748D6-4ECE-4283-A6F4-86A90159F621}"/>
+                <a16:creationId xmlns:a16="http://schemas.microsoft.com/office/drawing/2014/main" id="{12B508F7-3E76-4E73-B7CD-3C95BA67A07C}"/>
               </a:ext>
             </a:extLst>
           </p:cNvPr>
@@ -2885,7 +2885,7 @@
     </p:spTree>
     <p:extLst>
       <p:ext uri="{BB962C8B-B14F-4D97-AF65-F5344CB8AC3E}">
-        <p14:creationId xmlns:p14="http://schemas.microsoft.com/office/powerpoint/2010/main" val="692879200"/>
+        <p14:creationId xmlns:p14="http://schemas.microsoft.com/office/powerpoint/2010/main" val="1297216173"/>
       </p:ext>
     </p:extLst>
   </p:cSld>
@@ -2916,7 +2916,7 @@
           <p:cNvPr id="30" name="kicker-3">
             <a:extLst xmlns:a="http://schemas.openxmlformats.org/drawingml/2006/main">
               <a:ext uri="{FF2B5EF4-FFF2-40B4-BE49-F238E27FC236}">
-                <a16:creationId xmlns:a16="http://schemas.microsoft.com/office/drawing/2014/main" id="{56880CBD-9C24-42CE-A3EF-CBE4906FE2F2}"/>
+                <a16:creationId xmlns:a16="http://schemas.microsoft.com/office/drawing/2014/main" id="{FBFE4836-6681-4173-A99F-C19EC3BFC421}"/>
               </a:ext>
             </a:extLst>
           </p:cNvPr>
@@ -2974,7 +2974,7 @@
           <p:cNvPr id="2" name="title-3">
             <a:extLst xmlns:a="http://schemas.openxmlformats.org/drawingml/2006/main">
               <a:ext uri="{FF2B5EF4-FFF2-40B4-BE49-F238E27FC236}">
-                <a16:creationId xmlns:a16="http://schemas.microsoft.com/office/drawing/2014/main" id="{E70BA92C-1233-4A77-B322-571AD07D0CCA}"/>
+                <a16:creationId xmlns:a16="http://schemas.microsoft.com/office/drawing/2014/main" id="{EFAD5337-1A39-4FF8-A145-1ED56B06BDD1}"/>
               </a:ext>
             </a:extLst>
           </p:cNvPr>
@@ -3032,7 +3032,7 @@
           <p:cNvPr id="3" name="header-rule-3">
             <a:extLst xmlns:a="http://schemas.openxmlformats.org/drawingml/2006/main">
               <a:ext uri="{FF2B5EF4-FFF2-40B4-BE49-F238E27FC236}">
-                <a16:creationId xmlns:a16="http://schemas.microsoft.com/office/drawing/2014/main" id="{8D0FD924-1118-4135-B14E-6EFC3F274AD1}"/>
+                <a16:creationId xmlns:a16="http://schemas.microsoft.com/office/drawing/2014/main" id="{C66BFCCD-9758-4832-AAC1-5505F085BB4B}"/>
               </a:ext>
             </a:extLst>
           </p:cNvPr>
@@ -3065,7 +3065,7 @@
           <p:cNvPr id="4" name="page-3">
             <a:extLst xmlns:a="http://schemas.openxmlformats.org/drawingml/2006/main">
               <a:ext uri="{FF2B5EF4-FFF2-40B4-BE49-F238E27FC236}">
-                <a16:creationId xmlns:a16="http://schemas.microsoft.com/office/drawing/2014/main" id="{663643E0-EA0A-4CB2-855D-9AF32F700124}"/>
+                <a16:creationId xmlns:a16="http://schemas.microsoft.com/office/drawing/2014/main" id="{A7DEED41-DFC9-416E-A322-369021169EA6}"/>
               </a:ext>
             </a:extLst>
           </p:cNvPr>
@@ -3123,7 +3123,7 @@
           <p:cNvPr id="5" name="flow-line-0">
             <a:extLst xmlns:a="http://schemas.openxmlformats.org/drawingml/2006/main">
               <a:ext uri="{FF2B5EF4-FFF2-40B4-BE49-F238E27FC236}">
-                <a16:creationId xmlns:a16="http://schemas.microsoft.com/office/drawing/2014/main" id="{FD7CEAA0-BB38-4F7D-ACC3-33E5619D2104}"/>
+                <a16:creationId xmlns:a16="http://schemas.microsoft.com/office/drawing/2014/main" id="{F13433F9-DC4B-478C-9301-5EAD5E133A69}"/>
               </a:ext>
             </a:extLst>
           </p:cNvPr>
@@ -3156,7 +3156,7 @@
           <p:cNvPr id="6" name="flow-line-1">
             <a:extLst xmlns:a="http://schemas.openxmlformats.org/drawingml/2006/main">
               <a:ext uri="{FF2B5EF4-FFF2-40B4-BE49-F238E27FC236}">
-                <a16:creationId xmlns:a16="http://schemas.microsoft.com/office/drawing/2014/main" id="{AEBF95AD-8BC9-40A0-B738-1495BF4DB92B}"/>
+                <a16:creationId xmlns:a16="http://schemas.microsoft.com/office/drawing/2014/main" id="{E6208017-C576-42B9-B05E-82E81388621E}"/>
               </a:ext>
             </a:extLst>
           </p:cNvPr>
@@ -3189,7 +3189,7 @@
           <p:cNvPr id="7" name="flow-line-2">
             <a:extLst xmlns:a="http://schemas.openxmlformats.org/drawingml/2006/main">
               <a:ext uri="{FF2B5EF4-FFF2-40B4-BE49-F238E27FC236}">
-                <a16:creationId xmlns:a16="http://schemas.microsoft.com/office/drawing/2014/main" id="{03FD634D-661B-426D-A78C-829278C23A33}"/>
+                <a16:creationId xmlns:a16="http://schemas.microsoft.com/office/drawing/2014/main" id="{AB8907A9-CCFE-4260-BAB4-54F1D3109C70}"/>
               </a:ext>
             </a:extLst>
           </p:cNvPr>
@@ -3222,7 +3222,7 @@
           <p:cNvPr id="8" name="flow-line-3">
             <a:extLst xmlns:a="http://schemas.openxmlformats.org/drawingml/2006/main">
               <a:ext uri="{FF2B5EF4-FFF2-40B4-BE49-F238E27FC236}">
-                <a16:creationId xmlns:a16="http://schemas.microsoft.com/office/drawing/2014/main" id="{CB9CBBD3-4C9B-4FD6-AB63-A2E932D369EC}"/>
+                <a16:creationId xmlns:a16="http://schemas.microsoft.com/office/drawing/2014/main" id="{C4F31FBE-4B0D-4D9C-8C21-CCACDE2EF08D}"/>
               </a:ext>
             </a:extLst>
           </p:cNvPr>
@@ -3255,7 +3255,7 @@
           <p:cNvPr id="9" name="flow-line-4">
             <a:extLst xmlns:a="http://schemas.openxmlformats.org/drawingml/2006/main">
               <a:ext uri="{FF2B5EF4-FFF2-40B4-BE49-F238E27FC236}">
-                <a16:creationId xmlns:a16="http://schemas.microsoft.com/office/drawing/2014/main" id="{A4DFDE57-AD8A-4C93-9718-0DC0FCC06F9F}"/>
+                <a16:creationId xmlns:a16="http://schemas.microsoft.com/office/drawing/2014/main" id="{D2B8D89F-1AFF-404A-BDEF-46801E5D3F4D}"/>
               </a:ext>
             </a:extLst>
           </p:cNvPr>
@@ -3288,7 +3288,7 @@
           <p:cNvPr id="10" name="flow-num-0">
             <a:extLst xmlns:a="http://schemas.openxmlformats.org/drawingml/2006/main">
               <a:ext uri="{FF2B5EF4-FFF2-40B4-BE49-F238E27FC236}">
-                <a16:creationId xmlns:a16="http://schemas.microsoft.com/office/drawing/2014/main" id="{C09A133C-7ADA-41F1-BF91-441224DC8949}"/>
+                <a16:creationId xmlns:a16="http://schemas.microsoft.com/office/drawing/2014/main" id="{8C0590D9-AA2B-4411-AB91-8ACEDEF9CE31}"/>
               </a:ext>
             </a:extLst>
           </p:cNvPr>
@@ -3346,7 +3346,7 @@
           <p:cNvPr id="11" name="flow-label-0">
             <a:extLst xmlns:a="http://schemas.openxmlformats.org/drawingml/2006/main">
               <a:ext uri="{FF2B5EF4-FFF2-40B4-BE49-F238E27FC236}">
-                <a16:creationId xmlns:a16="http://schemas.microsoft.com/office/drawing/2014/main" id="{543EFFD0-6CBD-4B16-B9A0-15F796FF898D}"/>
+                <a16:creationId xmlns:a16="http://schemas.microsoft.com/office/drawing/2014/main" id="{F1202374-60AC-4607-B725-3AA6267B6A4C}"/>
               </a:ext>
             </a:extLst>
           </p:cNvPr>
@@ -3404,7 +3404,7 @@
           <p:cNvPr id="12" name="flow-detail-0">
             <a:extLst xmlns:a="http://schemas.openxmlformats.org/drawingml/2006/main">
               <a:ext uri="{FF2B5EF4-FFF2-40B4-BE49-F238E27FC236}">
-                <a16:creationId xmlns:a16="http://schemas.microsoft.com/office/drawing/2014/main" id="{8E8B22F2-654B-499C-AADF-FB5C0C84B6F0}"/>
+                <a16:creationId xmlns:a16="http://schemas.microsoft.com/office/drawing/2014/main" id="{3A4AED2D-8A45-4F5D-879F-649193CAD374}"/>
               </a:ext>
             </a:extLst>
           </p:cNvPr>
@@ -3462,7 +3462,7 @@
           <p:cNvPr id="13" name="flow-num-1">
             <a:extLst xmlns:a="http://schemas.openxmlformats.org/drawingml/2006/main">
               <a:ext uri="{FF2B5EF4-FFF2-40B4-BE49-F238E27FC236}">
-                <a16:creationId xmlns:a16="http://schemas.microsoft.com/office/drawing/2014/main" id="{807532D2-45B4-43DF-8F02-2BC310C251A4}"/>
+                <a16:creationId xmlns:a16="http://schemas.microsoft.com/office/drawing/2014/main" id="{AAFDB288-47CF-4B78-90CD-920BB92D2DAD}"/>
               </a:ext>
             </a:extLst>
           </p:cNvPr>
@@ -3520,7 +3520,7 @@
           <p:cNvPr id="14" name="flow-label-1">
             <a:extLst xmlns:a="http://schemas.openxmlformats.org/drawingml/2006/main">
               <a:ext uri="{FF2B5EF4-FFF2-40B4-BE49-F238E27FC236}">
-                <a16:creationId xmlns:a16="http://schemas.microsoft.com/office/drawing/2014/main" id="{A90FA509-247E-4A17-B11F-FDB1F1F25A7C}"/>
+                <a16:creationId xmlns:a16="http://schemas.microsoft.com/office/drawing/2014/main" id="{571D7781-633D-4EAB-A9DA-AD11DFF6D881}"/>
               </a:ext>
             </a:extLst>
           </p:cNvPr>
@@ -3578,7 +3578,7 @@
           <p:cNvPr id="15" name="flow-detail-1">
             <a:extLst xmlns:a="http://schemas.openxmlformats.org/drawingml/2006/main">
               <a:ext uri="{FF2B5EF4-FFF2-40B4-BE49-F238E27FC236}">
-                <a16:creationId xmlns:a16="http://schemas.microsoft.com/office/drawing/2014/main" id="{E0325324-76FA-4FC5-BD98-E53FCCF8EC57}"/>
+                <a16:creationId xmlns:a16="http://schemas.microsoft.com/office/drawing/2014/main" id="{E719308B-4B18-42A3-848C-C52898EBE289}"/>
               </a:ext>
             </a:extLst>
           </p:cNvPr>
@@ -3636,7 +3636,7 @@
           <p:cNvPr id="16" name="flow-num-2">
             <a:extLst xmlns:a="http://schemas.openxmlformats.org/drawingml/2006/main">
               <a:ext uri="{FF2B5EF4-FFF2-40B4-BE49-F238E27FC236}">
-                <a16:creationId xmlns:a16="http://schemas.microsoft.com/office/drawing/2014/main" id="{5B736497-6323-4984-93D7-98B2F12EED63}"/>
+                <a16:creationId xmlns:a16="http://schemas.microsoft.com/office/drawing/2014/main" id="{91CE1099-A988-46CC-8AAA-7FA63B41DAA9}"/>
               </a:ext>
             </a:extLst>
           </p:cNvPr>
@@ -3694,7 +3694,7 @@
           <p:cNvPr id="17" name="flow-label-2">
             <a:extLst xmlns:a="http://schemas.openxmlformats.org/drawingml/2006/main">
               <a:ext uri="{FF2B5EF4-FFF2-40B4-BE49-F238E27FC236}">
-                <a16:creationId xmlns:a16="http://schemas.microsoft.com/office/drawing/2014/main" id="{0896D293-BF48-421F-A39C-157EE7C06409}"/>
+                <a16:creationId xmlns:a16="http://schemas.microsoft.com/office/drawing/2014/main" id="{438F9D2F-2130-44EE-A789-0B48A71A64B1}"/>
               </a:ext>
             </a:extLst>
           </p:cNvPr>
@@ -3752,7 +3752,7 @@
           <p:cNvPr id="18" name="flow-detail-2">
             <a:extLst xmlns:a="http://schemas.openxmlformats.org/drawingml/2006/main">
               <a:ext uri="{FF2B5EF4-FFF2-40B4-BE49-F238E27FC236}">
-                <a16:creationId xmlns:a16="http://schemas.microsoft.com/office/drawing/2014/main" id="{AE5450B8-D544-41DA-B80E-6631D772AF56}"/>
+                <a16:creationId xmlns:a16="http://schemas.microsoft.com/office/drawing/2014/main" id="{B23157B4-F653-4D93-AF9B-FE252DC9AB11}"/>
               </a:ext>
             </a:extLst>
           </p:cNvPr>
@@ -3810,7 +3810,7 @@
           <p:cNvPr id="19" name="flow-num-3">
             <a:extLst xmlns:a="http://schemas.openxmlformats.org/drawingml/2006/main">
               <a:ext uri="{FF2B5EF4-FFF2-40B4-BE49-F238E27FC236}">
-                <a16:creationId xmlns:a16="http://schemas.microsoft.com/office/drawing/2014/main" id="{7B75F3D5-8D61-4E4C-B649-71BE0C34AE8D}"/>
+                <a16:creationId xmlns:a16="http://schemas.microsoft.com/office/drawing/2014/main" id="{E749A2AF-5D83-435A-BDF7-0588821849C6}"/>
               </a:ext>
             </a:extLst>
           </p:cNvPr>
@@ -3868,7 +3868,7 @@
           <p:cNvPr id="20" name="flow-label-3">
             <a:extLst xmlns:a="http://schemas.openxmlformats.org/drawingml/2006/main">
               <a:ext uri="{FF2B5EF4-FFF2-40B4-BE49-F238E27FC236}">
-                <a16:creationId xmlns:a16="http://schemas.microsoft.com/office/drawing/2014/main" id="{DEC2AD5D-A40D-438F-88B8-F45F8093E0F2}"/>
+                <a16:creationId xmlns:a16="http://schemas.microsoft.com/office/drawing/2014/main" id="{71262C77-AB4A-4D87-936B-A03838D3DE5B}"/>
               </a:ext>
             </a:extLst>
           </p:cNvPr>
@@ -3926,7 +3926,7 @@
           <p:cNvPr id="21" name="flow-detail-3">
             <a:extLst xmlns:a="http://schemas.openxmlformats.org/drawingml/2006/main">
               <a:ext uri="{FF2B5EF4-FFF2-40B4-BE49-F238E27FC236}">
-                <a16:creationId xmlns:a16="http://schemas.microsoft.com/office/drawing/2014/main" id="{2A95CFA0-1215-40AC-A408-BD757B37F934}"/>
+                <a16:creationId xmlns:a16="http://schemas.microsoft.com/office/drawing/2014/main" id="{BBB3A498-EBD6-4F54-8660-9441B4B399C1}"/>
               </a:ext>
             </a:extLst>
           </p:cNvPr>
@@ -3984,7 +3984,7 @@
           <p:cNvPr id="22" name="flow-num-4">
             <a:extLst xmlns:a="http://schemas.openxmlformats.org/drawingml/2006/main">
               <a:ext uri="{FF2B5EF4-FFF2-40B4-BE49-F238E27FC236}">
-                <a16:creationId xmlns:a16="http://schemas.microsoft.com/office/drawing/2014/main" id="{B8B32962-2904-47CA-A212-36168789A6DB}"/>
+                <a16:creationId xmlns:a16="http://schemas.microsoft.com/office/drawing/2014/main" id="{F19534B9-9873-4298-9639-BFD920E99540}"/>
               </a:ext>
             </a:extLst>
           </p:cNvPr>
@@ -4042,7 +4042,7 @@
           <p:cNvPr id="23" name="flow-label-4">
             <a:extLst xmlns:a="http://schemas.openxmlformats.org/drawingml/2006/main">
               <a:ext uri="{FF2B5EF4-FFF2-40B4-BE49-F238E27FC236}">
-                <a16:creationId xmlns:a16="http://schemas.microsoft.com/office/drawing/2014/main" id="{A9E484DF-F3B3-49C9-BA4C-B0E7D762307F}"/>
+                <a16:creationId xmlns:a16="http://schemas.microsoft.com/office/drawing/2014/main" id="{0B392FC8-C2E0-4F4F-9AAF-00465D4F0809}"/>
               </a:ext>
             </a:extLst>
           </p:cNvPr>
@@ -4100,7 +4100,7 @@
           <p:cNvPr id="24" name="flow-detail-4">
             <a:extLst xmlns:a="http://schemas.openxmlformats.org/drawingml/2006/main">
               <a:ext uri="{FF2B5EF4-FFF2-40B4-BE49-F238E27FC236}">
-                <a16:creationId xmlns:a16="http://schemas.microsoft.com/office/drawing/2014/main" id="{1321BF6C-7B4B-4EDA-ACBC-D42A97718185}"/>
+                <a16:creationId xmlns:a16="http://schemas.microsoft.com/office/drawing/2014/main" id="{61F5E19F-3AC7-4E04-993F-E3CB38DFC743}"/>
               </a:ext>
             </a:extLst>
           </p:cNvPr>
@@ -4158,7 +4158,7 @@
           <p:cNvPr id="25" name="flow-num-5">
             <a:extLst xmlns:a="http://schemas.openxmlformats.org/drawingml/2006/main">
               <a:ext uri="{FF2B5EF4-FFF2-40B4-BE49-F238E27FC236}">
-                <a16:creationId xmlns:a16="http://schemas.microsoft.com/office/drawing/2014/main" id="{CEEF0671-7D00-43F5-B4AE-670208550753}"/>
+                <a16:creationId xmlns:a16="http://schemas.microsoft.com/office/drawing/2014/main" id="{30559A9D-F09F-4FD4-85FA-BBFD6F72324E}"/>
               </a:ext>
             </a:extLst>
           </p:cNvPr>
@@ -4216,7 +4216,7 @@
           <p:cNvPr id="26" name="flow-label-5">
             <a:extLst xmlns:a="http://schemas.openxmlformats.org/drawingml/2006/main">
               <a:ext uri="{FF2B5EF4-FFF2-40B4-BE49-F238E27FC236}">
-                <a16:creationId xmlns:a16="http://schemas.microsoft.com/office/drawing/2014/main" id="{3ABE3B58-95F9-41F6-B0C9-DDB5E7241614}"/>
+                <a16:creationId xmlns:a16="http://schemas.microsoft.com/office/drawing/2014/main" id="{3E41A9CF-224E-47B1-8764-37E2DF5086EE}"/>
               </a:ext>
             </a:extLst>
           </p:cNvPr>
@@ -4274,7 +4274,7 @@
           <p:cNvPr id="27" name="flow-detail-5">
             <a:extLst xmlns:a="http://schemas.openxmlformats.org/drawingml/2006/main">
               <a:ext uri="{FF2B5EF4-FFF2-40B4-BE49-F238E27FC236}">
-                <a16:creationId xmlns:a16="http://schemas.microsoft.com/office/drawing/2014/main" id="{5C1D5D19-D943-4BF0-9E42-599EC3716463}"/>
+                <a16:creationId xmlns:a16="http://schemas.microsoft.com/office/drawing/2014/main" id="{4AA330C7-9710-4F66-B460-4D9D0887D39C}"/>
               </a:ext>
             </a:extLst>
           </p:cNvPr>
@@ -4332,7 +4332,7 @@
           <p:cNvPr id="28" name="flow-eino">
             <a:extLst xmlns:a="http://schemas.openxmlformats.org/drawingml/2006/main">
               <a:ext uri="{FF2B5EF4-FFF2-40B4-BE49-F238E27FC236}">
-                <a16:creationId xmlns:a16="http://schemas.microsoft.com/office/drawing/2014/main" id="{1CA75CAC-7E86-45B5-994E-364987DF951F}"/>
+                <a16:creationId xmlns:a16="http://schemas.microsoft.com/office/drawing/2014/main" id="{AC940830-E6A7-4DCA-9B19-D88A25D0D602}"/>
               </a:ext>
             </a:extLst>
           </p:cNvPr>
@@ -4390,7 +4390,7 @@
           <p:cNvPr id="29" name="flow-degrade">
             <a:extLst xmlns:a="http://schemas.openxmlformats.org/drawingml/2006/main">
               <a:ext uri="{FF2B5EF4-FFF2-40B4-BE49-F238E27FC236}">
-                <a16:creationId xmlns:a16="http://schemas.microsoft.com/office/drawing/2014/main" id="{1005A9ED-337A-444A-BD69-57E600F65C0F}"/>
+                <a16:creationId xmlns:a16="http://schemas.microsoft.com/office/drawing/2014/main" id="{C45DA6E9-9395-462D-BE53-A5C4866919F3}"/>
               </a:ext>
             </a:extLst>
           </p:cNvPr>
@@ -4446,7 +4446,7 @@
     </p:spTree>
     <p:extLst>
       <p:ext uri="{BB962C8B-B14F-4D97-AF65-F5344CB8AC3E}">
-        <p14:creationId xmlns:p14="http://schemas.microsoft.com/office/powerpoint/2010/main" val="923516974"/>
+        <p14:creationId xmlns:p14="http://schemas.microsoft.com/office/powerpoint/2010/main" val="1653274306"/>
       </p:ext>
     </p:extLst>
   </p:cSld>
@@ -4477,7 +4477,7 @@
           <p:cNvPr id="12" name="kicker-4">
             <a:extLst xmlns:a="http://schemas.openxmlformats.org/drawingml/2006/main">
               <a:ext uri="{FF2B5EF4-FFF2-40B4-BE49-F238E27FC236}">
-                <a16:creationId xmlns:a16="http://schemas.microsoft.com/office/drawing/2014/main" id="{78E1E4C6-D6A1-410D-B19D-24A10E5B568D}"/>
+                <a16:creationId xmlns:a16="http://schemas.microsoft.com/office/drawing/2014/main" id="{FD67B8B2-830B-47CC-A640-0769A8A5D9BD}"/>
               </a:ext>
             </a:extLst>
           </p:cNvPr>
@@ -4535,7 +4535,7 @@
           <p:cNvPr id="2" name="title-4">
             <a:extLst xmlns:a="http://schemas.openxmlformats.org/drawingml/2006/main">
               <a:ext uri="{FF2B5EF4-FFF2-40B4-BE49-F238E27FC236}">
-                <a16:creationId xmlns:a16="http://schemas.microsoft.com/office/drawing/2014/main" id="{F7278CE5-F7BB-41E7-BE70-B0F92276E91F}"/>
+                <a16:creationId xmlns:a16="http://schemas.microsoft.com/office/drawing/2014/main" id="{F28BF23C-54E0-43F1-A003-57878B192C34}"/>
               </a:ext>
             </a:extLst>
           </p:cNvPr>
@@ -4593,7 +4593,7 @@
           <p:cNvPr id="3" name="header-rule-4">
             <a:extLst xmlns:a="http://schemas.openxmlformats.org/drawingml/2006/main">
               <a:ext uri="{FF2B5EF4-FFF2-40B4-BE49-F238E27FC236}">
-                <a16:creationId xmlns:a16="http://schemas.microsoft.com/office/drawing/2014/main" id="{2FA3F4A5-6D88-41E9-948C-E35883BF70A2}"/>
+                <a16:creationId xmlns:a16="http://schemas.microsoft.com/office/drawing/2014/main" id="{4F14E368-E78E-4011-82A4-57F713DEA6D5}"/>
               </a:ext>
             </a:extLst>
           </p:cNvPr>
@@ -4626,7 +4626,7 @@
           <p:cNvPr id="4" name="page-4">
             <a:extLst xmlns:a="http://schemas.openxmlformats.org/drawingml/2006/main">
               <a:ext uri="{FF2B5EF4-FFF2-40B4-BE49-F238E27FC236}">
-                <a16:creationId xmlns:a16="http://schemas.microsoft.com/office/drawing/2014/main" id="{6314F628-F8DF-44BA-BE82-D8884A98EEF9}"/>
+                <a16:creationId xmlns:a16="http://schemas.microsoft.com/office/drawing/2014/main" id="{91F9CDF3-0C03-469D-8C2A-70B9FA80E6F0}"/>
               </a:ext>
             </a:extLst>
           </p:cNvPr>
@@ -4684,7 +4684,7 @@
           <p:cNvPr id="5" name="safety-left-title">
             <a:extLst xmlns:a="http://schemas.openxmlformats.org/drawingml/2006/main">
               <a:ext uri="{FF2B5EF4-FFF2-40B4-BE49-F238E27FC236}">
-                <a16:creationId xmlns:a16="http://schemas.microsoft.com/office/drawing/2014/main" id="{0F5B1D91-720E-47C5-9C36-5900201DABE8}"/>
+                <a16:creationId xmlns:a16="http://schemas.microsoft.com/office/drawing/2014/main" id="{1AE88633-2039-4767-B751-C7929FA30D8E}"/>
               </a:ext>
             </a:extLst>
           </p:cNvPr>
@@ -4742,7 +4742,7 @@
           <p:cNvPr id="6" name="safety-left-body">
             <a:extLst xmlns:a="http://schemas.openxmlformats.org/drawingml/2006/main">
               <a:ext uri="{FF2B5EF4-FFF2-40B4-BE49-F238E27FC236}">
-                <a16:creationId xmlns:a16="http://schemas.microsoft.com/office/drawing/2014/main" id="{2559677B-772D-49C5-B847-C936B04B1798}"/>
+                <a16:creationId xmlns:a16="http://schemas.microsoft.com/office/drawing/2014/main" id="{10C351F7-8B89-4387-AD63-16E4C0E93DF4}"/>
               </a:ext>
             </a:extLst>
           </p:cNvPr>
@@ -4846,7 +4846,7 @@
           <p:cNvPr id="7" name="safety-right-title">
             <a:extLst xmlns:a="http://schemas.openxmlformats.org/drawingml/2006/main">
               <a:ext uri="{FF2B5EF4-FFF2-40B4-BE49-F238E27FC236}">
-                <a16:creationId xmlns:a16="http://schemas.microsoft.com/office/drawing/2014/main" id="{1024C9D1-FD79-4212-A70C-111C88BA1B3D}"/>
+                <a16:creationId xmlns:a16="http://schemas.microsoft.com/office/drawing/2014/main" id="{D83390D6-0A00-4560-B51E-CEA236FE96F5}"/>
               </a:ext>
             </a:extLst>
           </p:cNvPr>
@@ -4904,7 +4904,7 @@
           <p:cNvPr id="8" name="safety-right-body">
             <a:extLst xmlns:a="http://schemas.openxmlformats.org/drawingml/2006/main">
               <a:ext uri="{FF2B5EF4-FFF2-40B4-BE49-F238E27FC236}">
-                <a16:creationId xmlns:a16="http://schemas.microsoft.com/office/drawing/2014/main" id="{DCB27BBE-86B9-46DF-B2D3-E0578EC495E8}"/>
+                <a16:creationId xmlns:a16="http://schemas.microsoft.com/office/drawing/2014/main" id="{420FD421-5DDA-4D1B-999E-AFE5E3737CF4}"/>
               </a:ext>
             </a:extLst>
           </p:cNvPr>
@@ -5008,7 +5008,7 @@
           <p:cNvPr id="9" name="safety-divider">
             <a:extLst xmlns:a="http://schemas.openxmlformats.org/drawingml/2006/main">
               <a:ext uri="{FF2B5EF4-FFF2-40B4-BE49-F238E27FC236}">
-                <a16:creationId xmlns:a16="http://schemas.microsoft.com/office/drawing/2014/main" id="{B1428BB2-C61B-4774-87B3-6A147525263A}"/>
+                <a16:creationId xmlns:a16="http://schemas.microsoft.com/office/drawing/2014/main" id="{1A330905-4EB2-468C-B1A7-A69E9C70ABA1}"/>
               </a:ext>
             </a:extLst>
           </p:cNvPr>
@@ -5041,7 +5041,7 @@
           <p:cNvPr id="10" name="safety-stop">
             <a:extLst xmlns:a="http://schemas.openxmlformats.org/drawingml/2006/main">
               <a:ext uri="{FF2B5EF4-FFF2-40B4-BE49-F238E27FC236}">
-                <a16:creationId xmlns:a16="http://schemas.microsoft.com/office/drawing/2014/main" id="{C16A3A99-5B6E-4564-8462-9043CAC41BC3}"/>
+                <a16:creationId xmlns:a16="http://schemas.microsoft.com/office/drawing/2014/main" id="{1379DDA8-04B5-4E9E-A723-ED0FEEE02FD0}"/>
               </a:ext>
             </a:extLst>
           </p:cNvPr>
@@ -5099,7 +5099,7 @@
           <p:cNvPr id="11" name="safety-privacy">
             <a:extLst xmlns:a="http://schemas.openxmlformats.org/drawingml/2006/main">
               <a:ext uri="{FF2B5EF4-FFF2-40B4-BE49-F238E27FC236}">
-                <a16:creationId xmlns:a16="http://schemas.microsoft.com/office/drawing/2014/main" id="{1DACF168-B098-4659-A762-93B369A18617}"/>
+                <a16:creationId xmlns:a16="http://schemas.microsoft.com/office/drawing/2014/main" id="{B4A8B71C-667C-49BF-8706-6B7764DCF91E}"/>
               </a:ext>
             </a:extLst>
           </p:cNvPr>
@@ -5155,7 +5155,7 @@
     </p:spTree>
     <p:extLst>
       <p:ext uri="{BB962C8B-B14F-4D97-AF65-F5344CB8AC3E}">
-        <p14:creationId xmlns:p14="http://schemas.microsoft.com/office/powerpoint/2010/main" val="308036632"/>
+        <p14:creationId xmlns:p14="http://schemas.microsoft.com/office/powerpoint/2010/main" val="1239450059"/>
       </p:ext>
     </p:extLst>
   </p:cSld>
@@ -5186,7 +5186,7 @@
           <p:cNvPr id="12" name="kicker-5">
             <a:extLst xmlns:a="http://schemas.openxmlformats.org/drawingml/2006/main">
               <a:ext uri="{FF2B5EF4-FFF2-40B4-BE49-F238E27FC236}">
-                <a16:creationId xmlns:a16="http://schemas.microsoft.com/office/drawing/2014/main" id="{B01CD56A-5313-4CDE-9D85-08F713279D71}"/>
+                <a16:creationId xmlns:a16="http://schemas.microsoft.com/office/drawing/2014/main" id="{892B6CAA-5149-4129-BC74-CC4E57127D5C}"/>
               </a:ext>
             </a:extLst>
           </p:cNvPr>
@@ -5244,7 +5244,7 @@
           <p:cNvPr id="2" name="title-5">
             <a:extLst xmlns:a="http://schemas.openxmlformats.org/drawingml/2006/main">
               <a:ext uri="{FF2B5EF4-FFF2-40B4-BE49-F238E27FC236}">
-                <a16:creationId xmlns:a16="http://schemas.microsoft.com/office/drawing/2014/main" id="{F3C08C1B-9EBB-4BBD-AE79-4542DC96DBC0}"/>
+                <a16:creationId xmlns:a16="http://schemas.microsoft.com/office/drawing/2014/main" id="{2239F834-5D6A-477D-9CA2-78BD2A9C3F64}"/>
               </a:ext>
             </a:extLst>
           </p:cNvPr>
@@ -5302,7 +5302,7 @@
           <p:cNvPr id="3" name="header-rule-5">
             <a:extLst xmlns:a="http://schemas.openxmlformats.org/drawingml/2006/main">
               <a:ext uri="{FF2B5EF4-FFF2-40B4-BE49-F238E27FC236}">
-                <a16:creationId xmlns:a16="http://schemas.microsoft.com/office/drawing/2014/main" id="{72F8A154-8700-498B-9CE6-092CB8431105}"/>
+                <a16:creationId xmlns:a16="http://schemas.microsoft.com/office/drawing/2014/main" id="{F37EAB5D-F3C8-4CA0-8A57-9C5D96D77B0E}"/>
               </a:ext>
             </a:extLst>
           </p:cNvPr>
@@ -5335,7 +5335,7 @@
           <p:cNvPr id="4" name="page-5">
             <a:extLst xmlns:a="http://schemas.openxmlformats.org/drawingml/2006/main">
               <a:ext uri="{FF2B5EF4-FFF2-40B4-BE49-F238E27FC236}">
-                <a16:creationId xmlns:a16="http://schemas.microsoft.com/office/drawing/2014/main" id="{F544A7FC-C0E5-498A-AE59-9842A0474AC8}"/>
+                <a16:creationId xmlns:a16="http://schemas.microsoft.com/office/drawing/2014/main" id="{057423DA-BAFB-4E87-A0D9-FDA9857AB25D}"/>
               </a:ext>
             </a:extLst>
           </p:cNvPr>
@@ -5393,7 +5393,7 @@
           <p:cNvPr id="5" name="code-entry-title">
             <a:extLst xmlns:a="http://schemas.openxmlformats.org/drawingml/2006/main">
               <a:ext uri="{FF2B5EF4-FFF2-40B4-BE49-F238E27FC236}">
-                <a16:creationId xmlns:a16="http://schemas.microsoft.com/office/drawing/2014/main" id="{656CCA2B-27EC-496C-BFE0-93F611413A89}"/>
+                <a16:creationId xmlns:a16="http://schemas.microsoft.com/office/drawing/2014/main" id="{0E92A31C-B279-4C8C-A4E3-DB2BB8737215}"/>
               </a:ext>
             </a:extLst>
           </p:cNvPr>
@@ -5451,7 +5451,7 @@
           <p:cNvPr id="6" name="code-entry-code">
             <a:extLst xmlns:a="http://schemas.openxmlformats.org/drawingml/2006/main">
               <a:ext uri="{FF2B5EF4-FFF2-40B4-BE49-F238E27FC236}">
-                <a16:creationId xmlns:a16="http://schemas.microsoft.com/office/drawing/2014/main" id="{D151EAB4-1E2D-4DB6-B6E1-934874088B4E}"/>
+                <a16:creationId xmlns:a16="http://schemas.microsoft.com/office/drawing/2014/main" id="{F4679A22-B3F5-48A3-8E36-AB3B1F4D58FD}"/>
               </a:ext>
             </a:extLst>
           </p:cNvPr>
@@ -5633,7 +5633,7 @@
           <p:cNvPr id="7" name="code-ai-title">
             <a:extLst xmlns:a="http://schemas.openxmlformats.org/drawingml/2006/main">
               <a:ext uri="{FF2B5EF4-FFF2-40B4-BE49-F238E27FC236}">
-                <a16:creationId xmlns:a16="http://schemas.microsoft.com/office/drawing/2014/main" id="{C8B6D096-D78B-431A-A54A-84EA6445B4FB}"/>
+                <a16:creationId xmlns:a16="http://schemas.microsoft.com/office/drawing/2014/main" id="{5BAF742B-B223-4D8D-AE41-34ED63CA0408}"/>
               </a:ext>
             </a:extLst>
           </p:cNvPr>
@@ -5691,7 +5691,7 @@
           <p:cNvPr id="8" name="code-ai-code">
             <a:extLst xmlns:a="http://schemas.openxmlformats.org/drawingml/2006/main">
               <a:ext uri="{FF2B5EF4-FFF2-40B4-BE49-F238E27FC236}">
-                <a16:creationId xmlns:a16="http://schemas.microsoft.com/office/drawing/2014/main" id="{4B386739-F278-41F8-A182-84FC5604DB4D}"/>
+                <a16:creationId xmlns:a16="http://schemas.microsoft.com/office/drawing/2014/main" id="{4064A576-273C-4490-912E-E6A5D6C5E905}"/>
               </a:ext>
             </a:extLst>
           </p:cNvPr>
@@ -5850,7 +5850,7 @@
           <p:cNvPr id="9" name="code-result-title">
             <a:extLst xmlns:a="http://schemas.openxmlformats.org/drawingml/2006/main">
               <a:ext uri="{FF2B5EF4-FFF2-40B4-BE49-F238E27FC236}">
-                <a16:creationId xmlns:a16="http://schemas.microsoft.com/office/drawing/2014/main" id="{2F2005B9-3C9D-4165-B69D-B0B2B4FCB4DC}"/>
+                <a16:creationId xmlns:a16="http://schemas.microsoft.com/office/drawing/2014/main" id="{7F786C40-D476-455D-A718-B842A7ADFEE6}"/>
               </a:ext>
             </a:extLst>
           </p:cNvPr>
@@ -5908,7 +5908,7 @@
           <p:cNvPr id="10" name="code-result-code">
             <a:extLst xmlns:a="http://schemas.openxmlformats.org/drawingml/2006/main">
               <a:ext uri="{FF2B5EF4-FFF2-40B4-BE49-F238E27FC236}">
-                <a16:creationId xmlns:a16="http://schemas.microsoft.com/office/drawing/2014/main" id="{5680F033-0C89-43A0-8557-CB6F60044B51}"/>
+                <a16:creationId xmlns:a16="http://schemas.microsoft.com/office/drawing/2014/main" id="{8AD1AB3A-7C85-4852-B2FA-8AA4B6819C3F}"/>
               </a:ext>
             </a:extLst>
           </p:cNvPr>
@@ -6011,7 +6011,7 @@
                 <a:ea typeface="Cascadia Mono"/>
                 <a:cs typeface="Cascadia Mono"/>
               </a:rPr>
-              <a:t>app.js:184–186</a:t>
+              <a:t>app.js:191–193</a:t>
             </a:r>
           </a:p>
           <a:p xmlns:a="http://schemas.openxmlformats.org/drawingml/2006/main">
@@ -6090,7 +6090,7 @@
           <p:cNvPr id="11" name="code-caption">
             <a:extLst xmlns:a="http://schemas.openxmlformats.org/drawingml/2006/main">
               <a:ext uri="{FF2B5EF4-FFF2-40B4-BE49-F238E27FC236}">
-                <a16:creationId xmlns:a16="http://schemas.microsoft.com/office/drawing/2014/main" id="{1EB7762C-4569-44A1-8951-5AA259440251}"/>
+                <a16:creationId xmlns:a16="http://schemas.microsoft.com/office/drawing/2014/main" id="{190496F4-B71B-4B15-B043-934890E0DD32}"/>
               </a:ext>
             </a:extLst>
           </p:cNvPr>
@@ -6146,7 +6146,7 @@
     </p:spTree>
     <p:extLst>
       <p:ext uri="{BB962C8B-B14F-4D97-AF65-F5344CB8AC3E}">
-        <p14:creationId xmlns:p14="http://schemas.microsoft.com/office/powerpoint/2010/main" val="1393645291"/>
+        <p14:creationId xmlns:p14="http://schemas.microsoft.com/office/powerpoint/2010/main" val="133402713"/>
       </p:ext>
     </p:extLst>
   </p:cSld>
@@ -6177,7 +6177,7 @@
           <p:cNvPr id="11" name="kicker-6">
             <a:extLst xmlns:a="http://schemas.openxmlformats.org/drawingml/2006/main">
               <a:ext uri="{FF2B5EF4-FFF2-40B4-BE49-F238E27FC236}">
-                <a16:creationId xmlns:a16="http://schemas.microsoft.com/office/drawing/2014/main" id="{4CCB2E88-397F-43BD-97BA-73548AE17696}"/>
+                <a16:creationId xmlns:a16="http://schemas.microsoft.com/office/drawing/2014/main" id="{06C26C10-5642-48CB-B553-F87F581AF252}"/>
               </a:ext>
             </a:extLst>
           </p:cNvPr>
@@ -6235,7 +6235,7 @@
           <p:cNvPr id="2" name="title-6">
             <a:extLst xmlns:a="http://schemas.openxmlformats.org/drawingml/2006/main">
               <a:ext uri="{FF2B5EF4-FFF2-40B4-BE49-F238E27FC236}">
-                <a16:creationId xmlns:a16="http://schemas.microsoft.com/office/drawing/2014/main" id="{46EBC02E-C8C7-4F34-BF36-942BB2931652}"/>
+                <a16:creationId xmlns:a16="http://schemas.microsoft.com/office/drawing/2014/main" id="{D76636D2-4180-4478-8CBA-6F9533F6C247}"/>
               </a:ext>
             </a:extLst>
           </p:cNvPr>
@@ -6293,7 +6293,7 @@
           <p:cNvPr id="3" name="header-rule-6">
             <a:extLst xmlns:a="http://schemas.openxmlformats.org/drawingml/2006/main">
               <a:ext uri="{FF2B5EF4-FFF2-40B4-BE49-F238E27FC236}">
-                <a16:creationId xmlns:a16="http://schemas.microsoft.com/office/drawing/2014/main" id="{0250EBF6-77FD-44EE-A61A-1049159D2BC0}"/>
+                <a16:creationId xmlns:a16="http://schemas.microsoft.com/office/drawing/2014/main" id="{C961CCCD-0541-48C0-B64B-DFB317430597}"/>
               </a:ext>
             </a:extLst>
           </p:cNvPr>
@@ -6326,7 +6326,7 @@
           <p:cNvPr id="4" name="page-6">
             <a:extLst xmlns:a="http://schemas.openxmlformats.org/drawingml/2006/main">
               <a:ext uri="{FF2B5EF4-FFF2-40B4-BE49-F238E27FC236}">
-                <a16:creationId xmlns:a16="http://schemas.microsoft.com/office/drawing/2014/main" id="{8327B08A-C81B-419E-A861-E31E0D5D03D8}"/>
+                <a16:creationId xmlns:a16="http://schemas.microsoft.com/office/drawing/2014/main" id="{CE7B441E-7411-4E27-9B5A-E267DD3A32FA}"/>
               </a:ext>
             </a:extLst>
           </p:cNvPr>
@@ -6384,7 +6384,7 @@
           <p:cNvPr id="5" name="docker-command">
             <a:extLst xmlns:a="http://schemas.openxmlformats.org/drawingml/2006/main">
               <a:ext uri="{FF2B5EF4-FFF2-40B4-BE49-F238E27FC236}">
-                <a16:creationId xmlns:a16="http://schemas.microsoft.com/office/drawing/2014/main" id="{820E843B-52C9-496B-9366-39F8DA0258D6}"/>
+                <a16:creationId xmlns:a16="http://schemas.microsoft.com/office/drawing/2014/main" id="{7E9ED4C3-5F47-45B5-87C0-77635346BF36}"/>
               </a:ext>
             </a:extLst>
           </p:cNvPr>
@@ -6444,7 +6444,7 @@
           <p:cNvPr id="6" name="container-proof">
             <a:extLst xmlns:a="http://schemas.openxmlformats.org/drawingml/2006/main">
               <a:ext uri="{FF2B5EF4-FFF2-40B4-BE49-F238E27FC236}">
-                <a16:creationId xmlns:a16="http://schemas.microsoft.com/office/drawing/2014/main" id="{58B620C2-FEA6-489B-A4ED-08CB1FC6E172}"/>
+                <a16:creationId xmlns:a16="http://schemas.microsoft.com/office/drawing/2014/main" id="{4E7F90D5-4294-4160-9A9F-E966C67044BA}"/>
               </a:ext>
             </a:extLst>
           </p:cNvPr>
@@ -6502,7 +6502,7 @@
           <p:cNvPr id="7" name="container-list">
             <a:extLst xmlns:a="http://schemas.openxmlformats.org/drawingml/2006/main">
               <a:ext uri="{FF2B5EF4-FFF2-40B4-BE49-F238E27FC236}">
-                <a16:creationId xmlns:a16="http://schemas.microsoft.com/office/drawing/2014/main" id="{F09C083A-19F4-45EC-A7AC-78F717DDB3EF}"/>
+                <a16:creationId xmlns:a16="http://schemas.microsoft.com/office/drawing/2014/main" id="{2BE66F28-3980-46B4-95D2-68C2A7187CE3}"/>
               </a:ext>
             </a:extLst>
           </p:cNvPr>
@@ -6629,7 +6629,7 @@
           <p:cNvPr id="8" name="quality-proof">
             <a:extLst xmlns:a="http://schemas.openxmlformats.org/drawingml/2006/main">
               <a:ext uri="{FF2B5EF4-FFF2-40B4-BE49-F238E27FC236}">
-                <a16:creationId xmlns:a16="http://schemas.microsoft.com/office/drawing/2014/main" id="{9BBC3CAA-E700-49CA-A125-F8E518DE17F3}"/>
+                <a16:creationId xmlns:a16="http://schemas.microsoft.com/office/drawing/2014/main" id="{246DAFD8-588E-4431-A4E1-873533D99BD0}"/>
               </a:ext>
             </a:extLst>
           </p:cNvPr>
@@ -6687,7 +6687,7 @@
           <p:cNvPr id="9" name="quality-list">
             <a:extLst xmlns:a="http://schemas.openxmlformats.org/drawingml/2006/main">
               <a:ext uri="{FF2B5EF4-FFF2-40B4-BE49-F238E27FC236}">
-                <a16:creationId xmlns:a16="http://schemas.microsoft.com/office/drawing/2014/main" id="{6CA0DCFD-75C1-42DA-BAE9-F82CA3897C64}"/>
+                <a16:creationId xmlns:a16="http://schemas.microsoft.com/office/drawing/2014/main" id="{D1C15A48-1F3D-4D4C-AC9A-1F841FF65D8D}"/>
               </a:ext>
             </a:extLst>
           </p:cNvPr>
@@ -6814,7 +6814,7 @@
           <p:cNvPr id="10" name="k8s-note">
             <a:extLst xmlns:a="http://schemas.openxmlformats.org/drawingml/2006/main">
               <a:ext uri="{FF2B5EF4-FFF2-40B4-BE49-F238E27FC236}">
-                <a16:creationId xmlns:a16="http://schemas.microsoft.com/office/drawing/2014/main" id="{53AD387D-2E3E-4E9D-BA36-663E2FBC78B3}"/>
+                <a16:creationId xmlns:a16="http://schemas.microsoft.com/office/drawing/2014/main" id="{6C40DAD3-DB69-4146-9083-93614194BCC9}"/>
               </a:ext>
             </a:extLst>
           </p:cNvPr>
@@ -6870,7 +6870,7 @@
     </p:spTree>
     <p:extLst>
       <p:ext uri="{BB962C8B-B14F-4D97-AF65-F5344CB8AC3E}">
-        <p14:creationId xmlns:p14="http://schemas.microsoft.com/office/powerpoint/2010/main" val="1448172845"/>
+        <p14:creationId xmlns:p14="http://schemas.microsoft.com/office/powerpoint/2010/main" val="1945920378"/>
       </p:ext>
     </p:extLst>
   </p:cSld>
@@ -6901,7 +6901,7 @@
           <p:cNvPr id="28" name="kicker-7">
             <a:extLst xmlns:a="http://schemas.openxmlformats.org/drawingml/2006/main">
               <a:ext uri="{FF2B5EF4-FFF2-40B4-BE49-F238E27FC236}">
-                <a16:creationId xmlns:a16="http://schemas.microsoft.com/office/drawing/2014/main" id="{B204B724-387C-4715-A9B7-8DCCEFA12324}"/>
+                <a16:creationId xmlns:a16="http://schemas.microsoft.com/office/drawing/2014/main" id="{80ED485C-FEF5-4DED-91EB-1DF3E2C54A13}"/>
               </a:ext>
             </a:extLst>
           </p:cNvPr>
@@ -6959,7 +6959,7 @@
           <p:cNvPr id="2" name="title-7">
             <a:extLst xmlns:a="http://schemas.openxmlformats.org/drawingml/2006/main">
               <a:ext uri="{FF2B5EF4-FFF2-40B4-BE49-F238E27FC236}">
-                <a16:creationId xmlns:a16="http://schemas.microsoft.com/office/drawing/2014/main" id="{13B0D0A5-3B2C-45A0-ABC0-70119CAF1807}"/>
+                <a16:creationId xmlns:a16="http://schemas.microsoft.com/office/drawing/2014/main" id="{AE6ED3BF-1162-40B4-9F24-B42ED1BD2C6A}"/>
               </a:ext>
             </a:extLst>
           </p:cNvPr>
@@ -7017,7 +7017,7 @@
           <p:cNvPr id="3" name="header-rule-7">
             <a:extLst xmlns:a="http://schemas.openxmlformats.org/drawingml/2006/main">
               <a:ext uri="{FF2B5EF4-FFF2-40B4-BE49-F238E27FC236}">
-                <a16:creationId xmlns:a16="http://schemas.microsoft.com/office/drawing/2014/main" id="{D8210AA3-9CBC-4C1C-89EF-CE189112C697}"/>
+                <a16:creationId xmlns:a16="http://schemas.microsoft.com/office/drawing/2014/main" id="{57B0FAC7-C8B5-4413-8543-21B08B43DFA2}"/>
               </a:ext>
             </a:extLst>
           </p:cNvPr>
@@ -7050,7 +7050,7 @@
           <p:cNvPr id="4" name="page-7">
             <a:extLst xmlns:a="http://schemas.openxmlformats.org/drawingml/2006/main">
               <a:ext uri="{FF2B5EF4-FFF2-40B4-BE49-F238E27FC236}">
-                <a16:creationId xmlns:a16="http://schemas.microsoft.com/office/drawing/2014/main" id="{1E4028AB-0775-4435-8364-A6A8EA6FC064}"/>
+                <a16:creationId xmlns:a16="http://schemas.microsoft.com/office/drawing/2014/main" id="{A5457AC6-BEAF-4B29-9A52-8798A16328A2}"/>
               </a:ext>
             </a:extLst>
           </p:cNvPr>
@@ -7108,7 +7108,7 @@
           <p:cNvPr id="5" name="timeline-rule">
             <a:extLst xmlns:a="http://schemas.openxmlformats.org/drawingml/2006/main">
               <a:ext uri="{FF2B5EF4-FFF2-40B4-BE49-F238E27FC236}">
-                <a16:creationId xmlns:a16="http://schemas.microsoft.com/office/drawing/2014/main" id="{6CF376E0-87E9-4CFA-874A-4392E0D096BC}"/>
+                <a16:creationId xmlns:a16="http://schemas.microsoft.com/office/drawing/2014/main" id="{47624BAD-DC93-4777-BF75-0064A2D0A159}"/>
               </a:ext>
             </a:extLst>
           </p:cNvPr>
@@ -7141,7 +7141,7 @@
           <p:cNvPr id="6" name="time-0">
             <a:extLst xmlns:a="http://schemas.openxmlformats.org/drawingml/2006/main">
               <a:ext uri="{FF2B5EF4-FFF2-40B4-BE49-F238E27FC236}">
-                <a16:creationId xmlns:a16="http://schemas.microsoft.com/office/drawing/2014/main" id="{3FF8B963-287C-4E7A-BE90-FDC9CF42A618}"/>
+                <a16:creationId xmlns:a16="http://schemas.microsoft.com/office/drawing/2014/main" id="{45B96A7A-0656-4444-9FEF-005855104A13}"/>
               </a:ext>
             </a:extLst>
           </p:cNvPr>
@@ -7199,7 +7199,7 @@
           <p:cNvPr id="7" name="time-name-0">
             <a:extLst xmlns:a="http://schemas.openxmlformats.org/drawingml/2006/main">
               <a:ext uri="{FF2B5EF4-FFF2-40B4-BE49-F238E27FC236}">
-                <a16:creationId xmlns:a16="http://schemas.microsoft.com/office/drawing/2014/main" id="{616B38AC-3A87-4C74-A2F1-D175701D303B}"/>
+                <a16:creationId xmlns:a16="http://schemas.microsoft.com/office/drawing/2014/main" id="{1DB674C3-BEDA-4051-885A-1222A3100D6E}"/>
               </a:ext>
             </a:extLst>
           </p:cNvPr>
@@ -7257,7 +7257,7 @@
           <p:cNvPr id="8" name="time-dot-0">
             <a:extLst xmlns:a="http://schemas.openxmlformats.org/drawingml/2006/main">
               <a:ext uri="{FF2B5EF4-FFF2-40B4-BE49-F238E27FC236}">
-                <a16:creationId xmlns:a16="http://schemas.microsoft.com/office/drawing/2014/main" id="{F5A00ED6-9F5A-4A4F-B585-99FEA8F47426}"/>
+                <a16:creationId xmlns:a16="http://schemas.microsoft.com/office/drawing/2014/main" id="{F2BE93D8-B033-47E2-AFC2-6031AC861413}"/>
               </a:ext>
             </a:extLst>
           </p:cNvPr>
@@ -7290,7 +7290,7 @@
           <p:cNvPr id="9" name="time-body-0">
             <a:extLst xmlns:a="http://schemas.openxmlformats.org/drawingml/2006/main">
               <a:ext uri="{FF2B5EF4-FFF2-40B4-BE49-F238E27FC236}">
-                <a16:creationId xmlns:a16="http://schemas.microsoft.com/office/drawing/2014/main" id="{576D8E21-65F9-46FC-97AB-DE7819E5D961}"/>
+                <a16:creationId xmlns:a16="http://schemas.microsoft.com/office/drawing/2014/main" id="{AB700C44-640D-4682-9BD8-3595630C4A91}"/>
               </a:ext>
             </a:extLst>
           </p:cNvPr>
@@ -7371,7 +7371,7 @@
           <p:cNvPr id="10" name="time-1">
             <a:extLst xmlns:a="http://schemas.openxmlformats.org/drawingml/2006/main">
               <a:ext uri="{FF2B5EF4-FFF2-40B4-BE49-F238E27FC236}">
-                <a16:creationId xmlns:a16="http://schemas.microsoft.com/office/drawing/2014/main" id="{DCC25846-27B2-48B1-A283-C8DCFF792A3D}"/>
+                <a16:creationId xmlns:a16="http://schemas.microsoft.com/office/drawing/2014/main" id="{928F2222-F15C-42C5-9252-4A07CA4E5B10}"/>
               </a:ext>
             </a:extLst>
           </p:cNvPr>
@@ -7429,7 +7429,7 @@
           <p:cNvPr id="11" name="time-name-1">
             <a:extLst xmlns:a="http://schemas.openxmlformats.org/drawingml/2006/main">
               <a:ext uri="{FF2B5EF4-FFF2-40B4-BE49-F238E27FC236}">
-                <a16:creationId xmlns:a16="http://schemas.microsoft.com/office/drawing/2014/main" id="{85A3B9E1-C581-467D-897D-97647732835F}"/>
+                <a16:creationId xmlns:a16="http://schemas.microsoft.com/office/drawing/2014/main" id="{C99E1803-829D-446E-AB62-660895D87DA1}"/>
               </a:ext>
             </a:extLst>
           </p:cNvPr>
@@ -7487,7 +7487,7 @@
           <p:cNvPr id="12" name="time-dot-1">
             <a:extLst xmlns:a="http://schemas.openxmlformats.org/drawingml/2006/main">
               <a:ext uri="{FF2B5EF4-FFF2-40B4-BE49-F238E27FC236}">
-                <a16:creationId xmlns:a16="http://schemas.microsoft.com/office/drawing/2014/main" id="{E125E949-86FC-4DF8-967D-62610907DD91}"/>
+                <a16:creationId xmlns:a16="http://schemas.microsoft.com/office/drawing/2014/main" id="{7B690903-14F2-4002-9ED3-7905ECECCAC8}"/>
               </a:ext>
             </a:extLst>
           </p:cNvPr>
@@ -7520,7 +7520,7 @@
           <p:cNvPr id="13" name="time-body-1">
             <a:extLst xmlns:a="http://schemas.openxmlformats.org/drawingml/2006/main">
               <a:ext uri="{FF2B5EF4-FFF2-40B4-BE49-F238E27FC236}">
-                <a16:creationId xmlns:a16="http://schemas.microsoft.com/office/drawing/2014/main" id="{C28C0E4B-9763-484F-BA22-03AFE9A7C16C}"/>
+                <a16:creationId xmlns:a16="http://schemas.microsoft.com/office/drawing/2014/main" id="{F90656CD-D645-43D2-964B-0B5ED9161347}"/>
               </a:ext>
             </a:extLst>
           </p:cNvPr>
@@ -7601,7 +7601,7 @@
           <p:cNvPr id="14" name="time-2">
             <a:extLst xmlns:a="http://schemas.openxmlformats.org/drawingml/2006/main">
               <a:ext uri="{FF2B5EF4-FFF2-40B4-BE49-F238E27FC236}">
-                <a16:creationId xmlns:a16="http://schemas.microsoft.com/office/drawing/2014/main" id="{F500525F-B995-49E2-B18B-3C80A2E97DAC}"/>
+                <a16:creationId xmlns:a16="http://schemas.microsoft.com/office/drawing/2014/main" id="{D88E4E7A-963E-46A2-85A4-17C33FAF65AA}"/>
               </a:ext>
             </a:extLst>
           </p:cNvPr>
@@ -7659,7 +7659,7 @@
           <p:cNvPr id="15" name="time-name-2">
             <a:extLst xmlns:a="http://schemas.openxmlformats.org/drawingml/2006/main">
               <a:ext uri="{FF2B5EF4-FFF2-40B4-BE49-F238E27FC236}">
-                <a16:creationId xmlns:a16="http://schemas.microsoft.com/office/drawing/2014/main" id="{8B721A36-07E3-49F7-AD6A-752590EC2671}"/>
+                <a16:creationId xmlns:a16="http://schemas.microsoft.com/office/drawing/2014/main" id="{17B38729-EC88-4C47-84A1-50FC867DC3C6}"/>
               </a:ext>
             </a:extLst>
           </p:cNvPr>
@@ -7717,7 +7717,7 @@
           <p:cNvPr id="16" name="time-dot-2">
             <a:extLst xmlns:a="http://schemas.openxmlformats.org/drawingml/2006/main">
               <a:ext uri="{FF2B5EF4-FFF2-40B4-BE49-F238E27FC236}">
-                <a16:creationId xmlns:a16="http://schemas.microsoft.com/office/drawing/2014/main" id="{3D355B4D-7C22-4848-B028-1F3FD1E53436}"/>
+                <a16:creationId xmlns:a16="http://schemas.microsoft.com/office/drawing/2014/main" id="{512AED55-EA57-4A4C-87D3-BB383655B3F8}"/>
               </a:ext>
             </a:extLst>
           </p:cNvPr>
@@ -7750,7 +7750,7 @@
           <p:cNvPr id="17" name="time-body-2">
             <a:extLst xmlns:a="http://schemas.openxmlformats.org/drawingml/2006/main">
               <a:ext uri="{FF2B5EF4-FFF2-40B4-BE49-F238E27FC236}">
-                <a16:creationId xmlns:a16="http://schemas.microsoft.com/office/drawing/2014/main" id="{AB220B71-100F-4EFE-BFC9-7C390841AA70}"/>
+                <a16:creationId xmlns:a16="http://schemas.microsoft.com/office/drawing/2014/main" id="{1CB252CC-C390-4693-ADB7-E385FDA8A0E0}"/>
               </a:ext>
             </a:extLst>
           </p:cNvPr>
@@ -7831,7 +7831,7 @@
           <p:cNvPr id="18" name="time-3">
             <a:extLst xmlns:a="http://schemas.openxmlformats.org/drawingml/2006/main">
               <a:ext uri="{FF2B5EF4-FFF2-40B4-BE49-F238E27FC236}">
-                <a16:creationId xmlns:a16="http://schemas.microsoft.com/office/drawing/2014/main" id="{C4D24920-96E0-4A33-AC57-259C00B138B9}"/>
+                <a16:creationId xmlns:a16="http://schemas.microsoft.com/office/drawing/2014/main" id="{00671417-7221-41FF-A903-3F48A38C9B8F}"/>
               </a:ext>
             </a:extLst>
           </p:cNvPr>
@@ -7889,7 +7889,7 @@
           <p:cNvPr id="19" name="time-name-3">
             <a:extLst xmlns:a="http://schemas.openxmlformats.org/drawingml/2006/main">
               <a:ext uri="{FF2B5EF4-FFF2-40B4-BE49-F238E27FC236}">
-                <a16:creationId xmlns:a16="http://schemas.microsoft.com/office/drawing/2014/main" id="{9B665D36-3276-47BA-ADCE-BED4F271D59E}"/>
+                <a16:creationId xmlns:a16="http://schemas.microsoft.com/office/drawing/2014/main" id="{8BA9AA1E-D8D2-43D9-8541-C2EB4D43B5A2}"/>
               </a:ext>
             </a:extLst>
           </p:cNvPr>
@@ -7947,7 +7947,7 @@
           <p:cNvPr id="20" name="time-dot-3">
             <a:extLst xmlns:a="http://schemas.openxmlformats.org/drawingml/2006/main">
               <a:ext uri="{FF2B5EF4-FFF2-40B4-BE49-F238E27FC236}">
-                <a16:creationId xmlns:a16="http://schemas.microsoft.com/office/drawing/2014/main" id="{936A41DB-8715-477C-AA39-A77E4A97CC19}"/>
+                <a16:creationId xmlns:a16="http://schemas.microsoft.com/office/drawing/2014/main" id="{A1F3BE30-06EA-4F89-9AA6-01BA109145B2}"/>
               </a:ext>
             </a:extLst>
           </p:cNvPr>
@@ -7980,7 +7980,7 @@
           <p:cNvPr id="21" name="time-body-3">
             <a:extLst xmlns:a="http://schemas.openxmlformats.org/drawingml/2006/main">
               <a:ext uri="{FF2B5EF4-FFF2-40B4-BE49-F238E27FC236}">
-                <a16:creationId xmlns:a16="http://schemas.microsoft.com/office/drawing/2014/main" id="{36E39136-513F-4C8C-B9FD-C9BB2CBF07B8}"/>
+                <a16:creationId xmlns:a16="http://schemas.microsoft.com/office/drawing/2014/main" id="{B1FB3456-53D5-4986-AF21-747DA48A97F6}"/>
               </a:ext>
             </a:extLst>
           </p:cNvPr>
@@ -8061,7 +8061,7 @@
           <p:cNvPr id="22" name="time-4">
             <a:extLst xmlns:a="http://schemas.openxmlformats.org/drawingml/2006/main">
               <a:ext uri="{FF2B5EF4-FFF2-40B4-BE49-F238E27FC236}">
-                <a16:creationId xmlns:a16="http://schemas.microsoft.com/office/drawing/2014/main" id="{092EBB43-33D6-464D-8F3A-477E7CF3B6F4}"/>
+                <a16:creationId xmlns:a16="http://schemas.microsoft.com/office/drawing/2014/main" id="{F0BB46A4-43BB-49E1-B222-E5B18DD5DA1C}"/>
               </a:ext>
             </a:extLst>
           </p:cNvPr>
@@ -8119,7 +8119,7 @@
           <p:cNvPr id="23" name="time-name-4">
             <a:extLst xmlns:a="http://schemas.openxmlformats.org/drawingml/2006/main">
               <a:ext uri="{FF2B5EF4-FFF2-40B4-BE49-F238E27FC236}">
-                <a16:creationId xmlns:a16="http://schemas.microsoft.com/office/drawing/2014/main" id="{5B856CCC-F8B2-4B19-BFB2-49B045832335}"/>
+                <a16:creationId xmlns:a16="http://schemas.microsoft.com/office/drawing/2014/main" id="{A74202A6-6AD9-4B82-BC6D-0F65B92655A8}"/>
               </a:ext>
             </a:extLst>
           </p:cNvPr>
@@ -8177,7 +8177,7 @@
           <p:cNvPr id="24" name="time-dot-4">
             <a:extLst xmlns:a="http://schemas.openxmlformats.org/drawingml/2006/main">
               <a:ext uri="{FF2B5EF4-FFF2-40B4-BE49-F238E27FC236}">
-                <a16:creationId xmlns:a16="http://schemas.microsoft.com/office/drawing/2014/main" id="{BCB05490-E2EA-4BA9-8E8E-014E37D936D1}"/>
+                <a16:creationId xmlns:a16="http://schemas.microsoft.com/office/drawing/2014/main" id="{5800D387-7A3C-48DF-92BF-D5B4DB2A4A8D}"/>
               </a:ext>
             </a:extLst>
           </p:cNvPr>
@@ -8210,7 +8210,7 @@
           <p:cNvPr id="25" name="time-body-4">
             <a:extLst xmlns:a="http://schemas.openxmlformats.org/drawingml/2006/main">
               <a:ext uri="{FF2B5EF4-FFF2-40B4-BE49-F238E27FC236}">
-                <a16:creationId xmlns:a16="http://schemas.microsoft.com/office/drawing/2014/main" id="{1A4A53BE-FFEE-44DB-8754-B794BD9CF079}"/>
+                <a16:creationId xmlns:a16="http://schemas.microsoft.com/office/drawing/2014/main" id="{290997F5-48A8-4685-992F-8DB5284485D9}"/>
               </a:ext>
             </a:extLst>
           </p:cNvPr>
@@ -8314,7 +8314,7 @@
           <p:cNvPr id="26" name="fallback-title">
             <a:extLst xmlns:a="http://schemas.openxmlformats.org/drawingml/2006/main">
               <a:ext uri="{FF2B5EF4-FFF2-40B4-BE49-F238E27FC236}">
-                <a16:creationId xmlns:a16="http://schemas.microsoft.com/office/drawing/2014/main" id="{021D2049-E63C-47D1-BFDE-34BE20EDF419}"/>
+                <a16:creationId xmlns:a16="http://schemas.microsoft.com/office/drawing/2014/main" id="{E670B12E-B3A7-4709-93AC-FA5863833454}"/>
               </a:ext>
             </a:extLst>
           </p:cNvPr>
@@ -8372,7 +8372,7 @@
           <p:cNvPr id="27" name="fallback-body">
             <a:extLst xmlns:a="http://schemas.openxmlformats.org/drawingml/2006/main">
               <a:ext uri="{FF2B5EF4-FFF2-40B4-BE49-F238E27FC236}">
-                <a16:creationId xmlns:a16="http://schemas.microsoft.com/office/drawing/2014/main" id="{08EFE3B3-2E38-4371-BDC4-7273494DB045}"/>
+                <a16:creationId xmlns:a16="http://schemas.microsoft.com/office/drawing/2014/main" id="{C4F143CD-8EEF-409D-AAA9-2D14229543B4}"/>
               </a:ext>
             </a:extLst>
           </p:cNvPr>
@@ -8428,7 +8428,7 @@
     </p:spTree>
     <p:extLst>
       <p:ext uri="{BB962C8B-B14F-4D97-AF65-F5344CB8AC3E}">
-        <p14:creationId xmlns:p14="http://schemas.microsoft.com/office/powerpoint/2010/main" val="106704902"/>
+        <p14:creationId xmlns:p14="http://schemas.microsoft.com/office/powerpoint/2010/main" val="1781533755"/>
       </p:ext>
     </p:extLst>
   </p:cSld>
@@ -8459,7 +8459,7 @@
           <p:cNvPr id="8" name="close-kicker">
             <a:extLst xmlns:a="http://schemas.openxmlformats.org/drawingml/2006/main">
               <a:ext uri="{FF2B5EF4-FFF2-40B4-BE49-F238E27FC236}">
-                <a16:creationId xmlns:a16="http://schemas.microsoft.com/office/drawing/2014/main" id="{6925F20D-DFE9-4909-A055-8C137499E68F}"/>
+                <a16:creationId xmlns:a16="http://schemas.microsoft.com/office/drawing/2014/main" id="{856F7DA9-738C-4B04-8649-0DAD75526F3B}"/>
               </a:ext>
             </a:extLst>
           </p:cNvPr>
@@ -8517,7 +8517,7 @@
           <p:cNvPr id="2" name="close-title">
             <a:extLst xmlns:a="http://schemas.openxmlformats.org/drawingml/2006/main">
               <a:ext uri="{FF2B5EF4-FFF2-40B4-BE49-F238E27FC236}">
-                <a16:creationId xmlns:a16="http://schemas.microsoft.com/office/drawing/2014/main" id="{549F4EF2-831D-4A9F-9EFE-479DADBD0603}"/>
+                <a16:creationId xmlns:a16="http://schemas.microsoft.com/office/drawing/2014/main" id="{16E965B3-259B-48D0-A590-C2ACBD258B44}"/>
               </a:ext>
             </a:extLst>
           </p:cNvPr>
@@ -8598,7 +8598,7 @@
           <p:cNvPr id="3" name="close-rule">
             <a:extLst xmlns:a="http://schemas.openxmlformats.org/drawingml/2006/main">
               <a:ext uri="{FF2B5EF4-FFF2-40B4-BE49-F238E27FC236}">
-                <a16:creationId xmlns:a16="http://schemas.microsoft.com/office/drawing/2014/main" id="{3FDC7FC8-465B-4A9D-82E1-F1F4DEC2174D}"/>
+                <a16:creationId xmlns:a16="http://schemas.microsoft.com/office/drawing/2014/main" id="{AD2EC54C-C083-4FD8-BF20-4D2D75247A92}"/>
               </a:ext>
             </a:extLst>
           </p:cNvPr>
@@ -8631,7 +8631,7 @@
           <p:cNvPr id="4" name="close-proof">
             <a:extLst xmlns:a="http://schemas.openxmlformats.org/drawingml/2006/main">
               <a:ext uri="{FF2B5EF4-FFF2-40B4-BE49-F238E27FC236}">
-                <a16:creationId xmlns:a16="http://schemas.microsoft.com/office/drawing/2014/main" id="{2A64358A-1075-4D9C-86B1-37A50A9DC5B3}"/>
+                <a16:creationId xmlns:a16="http://schemas.microsoft.com/office/drawing/2014/main" id="{5F9ABAA8-058D-47A1-AF0D-EA6C50C77D5B}"/>
               </a:ext>
             </a:extLst>
           </p:cNvPr>
@@ -8689,7 +8689,7 @@
           <p:cNvPr id="5" name="close-repo">
             <a:extLst xmlns:a="http://schemas.openxmlformats.org/drawingml/2006/main">
               <a:ext uri="{FF2B5EF4-FFF2-40B4-BE49-F238E27FC236}">
-                <a16:creationId xmlns:a16="http://schemas.microsoft.com/office/drawing/2014/main" id="{E4401C96-C125-4C7B-B431-3F001F0BE36A}"/>
+                <a16:creationId xmlns:a16="http://schemas.microsoft.com/office/drawing/2014/main" id="{D4346D59-E994-4E71-B3B2-647769CC1476}"/>
               </a:ext>
             </a:extLst>
           </p:cNvPr>
@@ -8747,7 +8747,7 @@
           <p:cNvPr id="6" name="close-url">
             <a:extLst xmlns:a="http://schemas.openxmlformats.org/drawingml/2006/main">
               <a:ext uri="{FF2B5EF4-FFF2-40B4-BE49-F238E27FC236}">
-                <a16:creationId xmlns:a16="http://schemas.microsoft.com/office/drawing/2014/main" id="{2983783A-3B05-4410-80AC-E1A174BDE244}"/>
+                <a16:creationId xmlns:a16="http://schemas.microsoft.com/office/drawing/2014/main" id="{234A1075-F9A2-4F9A-96F8-7449E9539C2C}"/>
               </a:ext>
             </a:extLst>
           </p:cNvPr>
@@ -8805,7 +8805,7 @@
           <p:cNvPr id="7" name="close-page">
             <a:extLst xmlns:a="http://schemas.openxmlformats.org/drawingml/2006/main">
               <a:ext uri="{FF2B5EF4-FFF2-40B4-BE49-F238E27FC236}">
-                <a16:creationId xmlns:a16="http://schemas.microsoft.com/office/drawing/2014/main" id="{CC272A47-9F8F-4C01-AC6B-DFC6AE329122}"/>
+                <a16:creationId xmlns:a16="http://schemas.microsoft.com/office/drawing/2014/main" id="{B53FA9EF-4365-4CC6-A531-1EC956EF00F8}"/>
               </a:ext>
             </a:extLst>
           </p:cNvPr>
@@ -8861,7 +8861,7 @@
     </p:spTree>
     <p:extLst>
       <p:ext uri="{BB962C8B-B14F-4D97-AF65-F5344CB8AC3E}">
-        <p14:creationId xmlns:p14="http://schemas.microsoft.com/office/powerpoint/2010/main" val="766754555"/>
+        <p14:creationId xmlns:p14="http://schemas.microsoft.com/office/powerpoint/2010/main" val="362830872"/>
       </p:ext>
     </p:extLst>
   </p:cSld>

</xml_diff>